<commit_message>
Add volatility-cone slide: upside/downside path envelope through time for both series (shared axes)
</commit_message>
<xml_diff>
--- a/Athanase_Downside_Risk_Outcomes.pptx
+++ b/Athanase_Downside_Risk_Outcomes.pptx
@@ -6,6 +6,7 @@
   </p:sldMasterIdLst>
   <p:sldIdLst>
     <p:sldId id="256" r:id="rId7"/>
+    <p:sldId id="257" r:id="rId8"/>
   </p:sldIdLst>
   <p:sldSz cx="9753600" cy="7315200" type="screen4x3"/>
   <p:notesSz cx="6858000" cy="9144000"/>
@@ -7004,6 +7005,436 @@
                 <a:latin typeface="Arial"/>
               </a:rPr>
               <a:t>Source: monthly net returns, 235 months (2006–2025). Volatility annualised from monthly; downside volatility = annualised deviation of negative months (MAR 0). *Adverse case = one downside-deviation outcome (≈1-in-6), narrowing with horizon as dd/√T. Illustrative; past performance is not indicative of future results.</a:t>
+            </a:r>
+          </a:p>
+        </p:txBody>
+      </p:sp>
+    </p:spTree>
+  </p:cSld>
+  <p:clrMapOvr>
+    <a:masterClrMapping/>
+  </p:clrMapOvr>
+</p:sld>
+</file>
+
+<file path=ppt/slides/slide2.xml><?xml version="1.0" encoding="utf-8"?>
+<p:sld xmlns:a="http://schemas.openxmlformats.org/drawingml/2006/main" xmlns:p="http://schemas.openxmlformats.org/presentationml/2006/main" xmlns:r="http://schemas.openxmlformats.org/officeDocument/2006/relationships">
+  <p:cSld>
+    <p:spTree>
+      <p:nvGrpSpPr>
+        <p:cNvPr id="1" name=""/>
+        <p:cNvGrpSpPr/>
+        <p:nvPr/>
+      </p:nvGrpSpPr>
+      <p:grpSpPr/>
+      <p:pic>
+        <p:nvPicPr>
+          <p:cNvPr id="2" name="Picture 1" descr="mark_dark.png"/>
+          <p:cNvPicPr>
+            <a:picLocks noChangeAspect="1"/>
+          </p:cNvPicPr>
+          <p:nvPr/>
+        </p:nvPicPr>
+        <p:blipFill>
+          <a:blip r:embed="rId2"/>
+          <a:stretch>
+            <a:fillRect/>
+          </a:stretch>
+        </p:blipFill>
+        <p:spPr>
+          <a:xfrm>
+            <a:off x="402346" y="234086"/>
+            <a:ext cx="224012" cy="190199"/>
+          </a:xfrm>
+          <a:prstGeom prst="rect">
+            <a:avLst/>
+          </a:prstGeom>
+        </p:spPr>
+      </p:pic>
+      <p:sp>
+        <p:nvSpPr>
+          <p:cNvPr id="3" name="TextBox 2"/>
+          <p:cNvSpPr txBox="1"/>
+          <p:nvPr/>
+        </p:nvSpPr>
+        <p:spPr>
+          <a:xfrm>
+            <a:off x="716907" y="263347"/>
+            <a:ext cx="5120768" cy="292608"/>
+          </a:xfrm>
+          <a:prstGeom prst="rect">
+            <a:avLst/>
+          </a:prstGeom>
+          <a:noFill/>
+        </p:spPr>
+        <p:txBody>
+          <a:bodyPr wrap="square" anchor="t" lIns="0" rIns="0" tIns="0" bIns="0">
+            <a:spAutoFit/>
+          </a:bodyPr>
+          <a:lstStyle/>
+          <a:p>
+            <a:pPr algn="l">
+              <a:lnSpc>
+                <a:spcPct val="110000"/>
+              </a:lnSpc>
+              <a:spcAft>
+                <a:spcPts val="0"/>
+              </a:spcAft>
+            </a:pPr>
+            <a:r>
+              <a:rPr sz="880" b="0" i="0">
+                <a:solidFill>
+                  <a:srgbClr val="556A83"/>
+                </a:solidFill>
+                <a:latin typeface="Arial"/>
+              </a:rPr>
+              <a:t>Risk-Adjusted Outcomes</a:t>
+            </a:r>
+          </a:p>
+        </p:txBody>
+      </p:sp>
+      <p:sp>
+        <p:nvSpPr>
+          <p:cNvPr id="4" name="TextBox 3"/>
+          <p:cNvSpPr txBox="1"/>
+          <p:nvPr/>
+        </p:nvSpPr>
+        <p:spPr>
+          <a:xfrm>
+            <a:off x="7242229" y="263347"/>
+            <a:ext cx="2084884" cy="292608"/>
+          </a:xfrm>
+          <a:prstGeom prst="rect">
+            <a:avLst/>
+          </a:prstGeom>
+          <a:noFill/>
+        </p:spPr>
+        <p:txBody>
+          <a:bodyPr wrap="square" anchor="t" lIns="0" rIns="0" tIns="0" bIns="0">
+            <a:spAutoFit/>
+          </a:bodyPr>
+          <a:lstStyle/>
+          <a:p>
+            <a:pPr algn="r">
+              <a:lnSpc>
+                <a:spcPct val="110000"/>
+              </a:lnSpc>
+              <a:spcAft>
+                <a:spcPts val="0"/>
+              </a:spcAft>
+            </a:pPr>
+            <a:r>
+              <a:rPr sz="880" b="1" i="0">
+                <a:solidFill>
+                  <a:srgbClr val="556A83"/>
+                </a:solidFill>
+                <a:latin typeface="Arial"/>
+              </a:rPr>
+              <a:t>Figure 2</a:t>
+            </a:r>
+          </a:p>
+        </p:txBody>
+      </p:sp>
+      <p:sp>
+        <p:nvSpPr>
+          <p:cNvPr id="5" name="Rectangle 4"/>
+          <p:cNvSpPr/>
+          <p:nvPr/>
+        </p:nvSpPr>
+        <p:spPr>
+          <a:xfrm>
+            <a:off x="0" y="604723"/>
+            <a:ext cx="9753600" cy="1414272"/>
+          </a:xfrm>
+          <a:prstGeom prst="rect">
+            <a:avLst/>
+          </a:prstGeom>
+          <a:solidFill>
+            <a:srgbClr val="F6F7F9"/>
+          </a:solidFill>
+          <a:ln>
+            <a:noFill/>
+          </a:ln>
+          <a:effectLst/>
+        </p:spPr>
+        <p:style>
+          <a:lnRef idx="1">
+            <a:schemeClr val="accent1"/>
+          </a:lnRef>
+          <a:fillRef idx="3">
+            <a:schemeClr val="accent1"/>
+          </a:fillRef>
+          <a:effectRef idx="2">
+            <a:schemeClr val="accent1"/>
+          </a:effectRef>
+          <a:fontRef idx="minor">
+            <a:schemeClr val="lt1"/>
+          </a:fontRef>
+        </p:style>
+        <p:txBody>
+          <a:bodyPr rtlCol="0" anchor="ctr"/>
+          <a:lstStyle/>
+          <a:p>
+            <a:pPr algn="ctr"/>
+          </a:p>
+        </p:txBody>
+      </p:sp>
+      <p:sp>
+        <p:nvSpPr>
+          <p:cNvPr id="6" name="TextBox 5"/>
+          <p:cNvSpPr txBox="1"/>
+          <p:nvPr/>
+        </p:nvSpPr>
+        <p:spPr>
+          <a:xfrm>
+            <a:off x="438922" y="721766"/>
+            <a:ext cx="8851613" cy="829056"/>
+          </a:xfrm>
+          <a:prstGeom prst="rect">
+            <a:avLst/>
+          </a:prstGeom>
+          <a:noFill/>
+        </p:spPr>
+        <p:txBody>
+          <a:bodyPr wrap="square" anchor="t" lIns="0" rIns="0" tIns="0" bIns="0">
+            <a:spAutoFit/>
+          </a:bodyPr>
+          <a:lstStyle/>
+          <a:p>
+            <a:pPr algn="l">
+              <a:lnSpc>
+                <a:spcPct val="110000"/>
+              </a:lnSpc>
+              <a:spcAft>
+                <a:spcPts val="200"/>
+              </a:spcAft>
+            </a:pPr>
+            <a:r>
+              <a:rPr sz="2400" b="0" i="0" spc="-90">
+                <a:solidFill>
+                  <a:srgbClr val="314359"/>
+                </a:solidFill>
+                <a:latin typeface="Times New Roman"/>
+              </a:rPr>
+              <a:t>The path through time — upside and downside envelope</a:t>
+            </a:r>
+          </a:p>
+        </p:txBody>
+      </p:sp>
+      <p:sp>
+        <p:nvSpPr>
+          <p:cNvPr id="7" name="TextBox 6"/>
+          <p:cNvSpPr txBox="1"/>
+          <p:nvPr/>
+        </p:nvSpPr>
+        <p:spPr>
+          <a:xfrm>
+            <a:off x="453553" y="1511808"/>
+            <a:ext cx="8705305" cy="487680"/>
+          </a:xfrm>
+          <a:prstGeom prst="rect">
+            <a:avLst/>
+          </a:prstGeom>
+          <a:noFill/>
+        </p:spPr>
+        <p:txBody>
+          <a:bodyPr wrap="square" anchor="t" lIns="0" rIns="0" tIns="0" bIns="0">
+            <a:spAutoFit/>
+          </a:bodyPr>
+          <a:lstStyle/>
+          <a:p>
+            <a:pPr algn="l">
+              <a:lnSpc>
+                <a:spcPct val="110000"/>
+              </a:lnSpc>
+              <a:spcAft>
+                <a:spcPts val="0"/>
+              </a:spcAft>
+            </a:pPr>
+            <a:r>
+              <a:rPr sz="1040" b="0" i="1">
+                <a:solidFill>
+                  <a:srgbClr val="556A83"/>
+                </a:solidFill>
+                <a:latin typeface="Arial"/>
+              </a:rPr>
+              <a:t>Same axes for both. Athanase’s cone fans wide on the upside but holds firm on the downside; the market’s is symmetric and far lower.</a:t>
+            </a:r>
+          </a:p>
+        </p:txBody>
+      </p:sp>
+      <p:pic>
+        <p:nvPicPr>
+          <p:cNvPr id="8" name="Picture 7" descr="cone_ath.png"/>
+          <p:cNvPicPr>
+            <a:picLocks noChangeAspect="1"/>
+          </p:cNvPicPr>
+          <p:nvPr/>
+        </p:nvPicPr>
+        <p:blipFill>
+          <a:blip r:embed="rId3"/>
+          <a:stretch>
+            <a:fillRect/>
+          </a:stretch>
+        </p:blipFill>
+        <p:spPr>
+          <a:xfrm>
+            <a:off x="329192" y="2194560"/>
+            <a:ext cx="3767380" cy="2962730"/>
+          </a:xfrm>
+          <a:prstGeom prst="rect">
+            <a:avLst/>
+          </a:prstGeom>
+        </p:spPr>
+      </p:pic>
+      <p:pic>
+        <p:nvPicPr>
+          <p:cNvPr id="9" name="Picture 8" descr="cone_msci.png"/>
+          <p:cNvPicPr>
+            <a:picLocks noChangeAspect="1"/>
+          </p:cNvPicPr>
+          <p:nvPr/>
+        </p:nvPicPr>
+        <p:blipFill>
+          <a:blip r:embed="rId4"/>
+          <a:stretch>
+            <a:fillRect/>
+          </a:stretch>
+        </p:blipFill>
+        <p:spPr>
+          <a:xfrm>
+            <a:off x="5011037" y="2194560"/>
+            <a:ext cx="3767380" cy="2962730"/>
+          </a:xfrm>
+          <a:prstGeom prst="rect">
+            <a:avLst/>
+          </a:prstGeom>
+        </p:spPr>
+      </p:pic>
+      <p:sp>
+        <p:nvSpPr>
+          <p:cNvPr id="10" name="Rectangle 9"/>
+          <p:cNvSpPr/>
+          <p:nvPr/>
+        </p:nvSpPr>
+        <p:spPr>
+          <a:xfrm>
+            <a:off x="438922" y="6339840"/>
+            <a:ext cx="8873559" cy="487680"/>
+          </a:xfrm>
+          <a:prstGeom prst="rect">
+            <a:avLst/>
+          </a:prstGeom>
+          <a:solidFill>
+            <a:srgbClr val="152130"/>
+          </a:solidFill>
+          <a:ln>
+            <a:noFill/>
+          </a:ln>
+          <a:effectLst/>
+        </p:spPr>
+        <p:style>
+          <a:lnRef idx="1">
+            <a:schemeClr val="accent1"/>
+          </a:lnRef>
+          <a:fillRef idx="3">
+            <a:schemeClr val="accent1"/>
+          </a:fillRef>
+          <a:effectRef idx="2">
+            <a:schemeClr val="accent1"/>
+          </a:effectRef>
+          <a:fontRef idx="minor">
+            <a:schemeClr val="lt1"/>
+          </a:fontRef>
+        </p:style>
+        <p:txBody>
+          <a:bodyPr rtlCol="0" anchor="ctr"/>
+          <a:lstStyle/>
+          <a:p>
+            <a:pPr algn="ctr"/>
+          </a:p>
+        </p:txBody>
+      </p:sp>
+      <p:sp>
+        <p:nvSpPr>
+          <p:cNvPr id="11" name="TextBox 10"/>
+          <p:cNvSpPr txBox="1"/>
+          <p:nvPr/>
+        </p:nvSpPr>
+        <p:spPr>
+          <a:xfrm>
+            <a:off x="570599" y="6339840"/>
+            <a:ext cx="8632151" cy="487680"/>
+          </a:xfrm>
+          <a:prstGeom prst="rect">
+            <a:avLst/>
+          </a:prstGeom>
+          <a:noFill/>
+        </p:spPr>
+        <p:txBody>
+          <a:bodyPr wrap="square" anchor="ctr" lIns="0" rIns="0" tIns="0" bIns="0">
+            <a:spAutoFit/>
+          </a:bodyPr>
+          <a:lstStyle/>
+          <a:p>
+            <a:pPr algn="l">
+              <a:lnSpc>
+                <a:spcPct val="110000"/>
+              </a:lnSpc>
+              <a:spcAft>
+                <a:spcPts val="0"/>
+              </a:spcAft>
+            </a:pPr>
+            <a:r>
+              <a:rPr sz="960" b="0" i="1">
+                <a:solidFill>
+                  <a:srgbClr val="FFFFFF"/>
+                </a:solidFill>
+                <a:latin typeface="Arial"/>
+              </a:rPr>
+              <a:t>Athanase upside deviation 25% vs downside 11% — the volatility is mostly upside. Even its 10-year downside edge stays above the market’s expected path.</a:t>
+            </a:r>
+          </a:p>
+        </p:txBody>
+      </p:sp>
+      <p:sp>
+        <p:nvSpPr>
+          <p:cNvPr id="12" name="TextBox 11"/>
+          <p:cNvSpPr txBox="1"/>
+          <p:nvPr/>
+        </p:nvSpPr>
+        <p:spPr>
+          <a:xfrm>
+            <a:off x="438922" y="6944563"/>
+            <a:ext cx="9217382" cy="390144"/>
+          </a:xfrm>
+          <a:prstGeom prst="rect">
+            <a:avLst/>
+          </a:prstGeom>
+          <a:noFill/>
+        </p:spPr>
+        <p:txBody>
+          <a:bodyPr wrap="square" anchor="t" lIns="0" rIns="0" tIns="0" bIns="0">
+            <a:spAutoFit/>
+          </a:bodyPr>
+          <a:lstStyle/>
+          <a:p>
+            <a:pPr algn="l">
+              <a:lnSpc>
+                <a:spcPct val="110000"/>
+              </a:lnSpc>
+              <a:spcAft>
+                <a:spcPts val="0"/>
+              </a:spcAft>
+            </a:pPr>
+            <a:r>
+              <a:rPr sz="600" b="0" i="0">
+                <a:solidFill>
+                  <a:srgbClr val="556A83"/>
+                </a:solidFill>
+                <a:latin typeface="Arial"/>
+              </a:rPr>
+              <a:t>Source: monthly net returns, 235 months (2006–2025). Envelope = expected path ±1 annualised up/downside deviation, widening with √time; faint lines are sample simulated paths. Illustrative; past performance is not indicative of future results.</a:t>
             </a:r>
           </a:p>
         </p:txBody>

</xml_diff>

<commit_message>
Combine volatility cones into one overlaid chart; remove illustrative random paths
</commit_message>
<xml_diff>
--- a/Athanase_Downside_Risk_Outcomes.pptx
+++ b/Athanase_Downside_Risk_Outcomes.pptx
@@ -7258,14 +7258,14 @@
                 </a:solidFill>
                 <a:latin typeface="Arial"/>
               </a:rPr>
-              <a:t>Same axes for both. Athanase’s cone fans wide on the upside but holds firm on the downside; the market’s is symmetric and far lower.</a:t>
+              <a:t>Both series, one scale. Athanase’s envelope fans wide on the upside but holds firm below — its downside edge stays above the market’s best case.</a:t>
             </a:r>
           </a:p>
         </p:txBody>
       </p:sp>
       <p:pic>
         <p:nvPicPr>
-          <p:cNvPr id="8" name="Picture 7" descr="cone_ath.png"/>
+          <p:cNvPr id="8" name="Picture 7" descr="cone_combined.png"/>
           <p:cNvPicPr>
             <a:picLocks noChangeAspect="1"/>
           </p:cNvPicPr>
@@ -7279,41 +7279,17 @@
         </p:blipFill>
         <p:spPr>
           <a:xfrm>
-            <a:off x="329192" y="2194560"/>
-            <a:ext cx="3767380" cy="2962730"/>
+            <a:off x="621807" y="2145792"/>
+            <a:ext cx="6261051" cy="2999306"/>
           </a:xfrm>
           <a:prstGeom prst="rect">
             <a:avLst/>
           </a:prstGeom>
         </p:spPr>
       </p:pic>
-      <p:pic>
-        <p:nvPicPr>
-          <p:cNvPr id="9" name="Picture 8" descr="cone_msci.png"/>
-          <p:cNvPicPr>
-            <a:picLocks noChangeAspect="1"/>
-          </p:cNvPicPr>
-          <p:nvPr/>
-        </p:nvPicPr>
-        <p:blipFill>
-          <a:blip r:embed="rId4"/>
-          <a:stretch>
-            <a:fillRect/>
-          </a:stretch>
-        </p:blipFill>
-        <p:spPr>
-          <a:xfrm>
-            <a:off x="5011037" y="2194560"/>
-            <a:ext cx="3767380" cy="2962730"/>
-          </a:xfrm>
-          <a:prstGeom prst="rect">
-            <a:avLst/>
-          </a:prstGeom>
-        </p:spPr>
-      </p:pic>
-      <p:sp>
-        <p:nvSpPr>
-          <p:cNvPr id="10" name="Rectangle 9"/>
+      <p:sp>
+        <p:nvSpPr>
+          <p:cNvPr id="9" name="Rectangle 8"/>
           <p:cNvSpPr/>
           <p:nvPr/>
         </p:nvSpPr>
@@ -7357,7 +7333,7 @@
       </p:sp>
       <p:sp>
         <p:nvSpPr>
-          <p:cNvPr id="11" name="TextBox 10"/>
+          <p:cNvPr id="10" name="TextBox 9"/>
           <p:cNvSpPr txBox="1"/>
           <p:nvPr/>
         </p:nvSpPr>
@@ -7399,7 +7375,7 @@
       </p:sp>
       <p:sp>
         <p:nvSpPr>
-          <p:cNvPr id="12" name="TextBox 11"/>
+          <p:cNvPr id="11" name="TextBox 10"/>
           <p:cNvSpPr txBox="1"/>
           <p:nvPr/>
         </p:nvSpPr>
@@ -7434,7 +7410,7 @@
                 </a:solidFill>
                 <a:latin typeface="Arial"/>
               </a:rPr>
-              <a:t>Source: monthly net returns, 235 months (2006–2025). Envelope = expected path ±1 annualised up/downside deviation, widening with √time; faint lines are sample simulated paths. Illustrative; past performance is not indicative of future results.</a:t>
+              <a:t>Source: monthly net returns, 235 months (2006–2025). Shaded band = expected path ±1 annualised up/downside deviation, widening with √time. Illustrative; past performance is not indicative of future results.</a:t>
             </a:r>
           </a:p>
         </p:txBody>

</xml_diff>

<commit_message>
Add Bridgewater All Weather cone (public estimate) to comparison; three-strategy view
</commit_message>
<xml_diff>
--- a/Athanase_Downside_Risk_Outcomes.pptx
+++ b/Athanase_Downside_Risk_Outcomes.pptx
@@ -7258,7 +7258,7 @@
                 </a:solidFill>
                 <a:latin typeface="Arial"/>
               </a:rPr>
-              <a:t>Both series, one scale. Athanase’s envelope fans wide on the upside but holds firm below — its downside edge stays above the market’s best case.</a:t>
+              <a:t>Three strategies, one scale. All Weather rides smooth but low; the market is symmetric and middling; Athanase fans wide up yet holds firm below.</a:t>
             </a:r>
           </a:p>
         </p:txBody>
@@ -7280,7 +7280,7 @@
         <p:spPr>
           <a:xfrm>
             <a:off x="621807" y="2145792"/>
-            <a:ext cx="6318993" cy="2999306"/>
+            <a:ext cx="6226968" cy="2999306"/>
           </a:xfrm>
           <a:prstGeom prst="rect">
             <a:avLst/>
@@ -7368,7 +7368,7 @@
                 </a:solidFill>
                 <a:latin typeface="Arial"/>
               </a:rPr>
-              <a:t>Athanase upside deviation 25% vs downside 11% — the volatility is mostly upside. Even its 10-year downside edge stays above the market’s expected path.</a:t>
+              <a:t>All Weather’s tight cone delivers the smoothest ride — but Athanase’s downside edge still clears All Weather’s and the market’s upside.</a:t>
             </a:r>
           </a:p>
         </p:txBody>
@@ -7381,8 +7381,8 @@
         </p:nvSpPr>
         <p:spPr>
           <a:xfrm>
-            <a:off x="438922" y="6944563"/>
-            <a:ext cx="9217382" cy="390144"/>
+            <a:off x="438922" y="6886041"/>
+            <a:ext cx="9217382" cy="438912"/>
           </a:xfrm>
           <a:prstGeom prst="rect">
             <a:avLst/>
@@ -7410,7 +7410,7 @@
                 </a:solidFill>
                 <a:latin typeface="Arial"/>
               </a:rPr>
-              <a:t>Source: monthly net returns, 235 months (2006–2025). Shaded band = expected path ±1 annualised up/downside deviation, widening with √time. Illustrative; past performance is not indicative of future results.</a:t>
+              <a:t>Source: monthly net returns, 235 months (2006–2025), for MSCI and Athanase. *Bridgewater All Weather shown from public estimates (~7% return, ~6.5/7.0% up/downside deviation), not a supplied return series. Shaded band = expected ±1 annualised up/downside deviation, widening with √time. Illustrative; past performance ≠ future results.</a:t>
             </a:r>
           </a:p>
         </p:txBody>

</xml_diff>

<commit_message>
Redesign slide 2 around allocator metrics: up/down capture, correlation/beta, rolling win-rate (drop All Weather + cone)
</commit_message>
<xml_diff>
--- a/Athanase_Downside_Risk_Outcomes.pptx
+++ b/Athanase_Downside_Risk_Outcomes.pptx
@@ -7216,7 +7216,7 @@
                 </a:solidFill>
                 <a:latin typeface="Times New Roman"/>
               </a:rPr>
-              <a:t>The path through time — upside and downside envelope</a:t>
+              <a:t>A complement to global equities, not a duplicate</a:t>
             </a:r>
           </a:p>
         </p:txBody>
@@ -7258,14 +7258,14 @@
                 </a:solidFill>
                 <a:latin typeface="Arial"/>
               </a:rPr>
-              <a:t>Three strategies, one scale. All Weather rides smooth but low; the market is symmetric and middling; Athanase fans wide up yet holds firm below.</a:t>
+              <a:t>What a global-equity holder asks of a new manager: do you keep up in rallies, lose less in selloffs, and add something the index can’t?</a:t>
             </a:r>
           </a:p>
         </p:txBody>
       </p:sp>
       <p:pic>
         <p:nvPicPr>
-          <p:cNvPr id="8" name="Picture 7" descr="cone_combined.png"/>
+          <p:cNvPr id="8" name="Picture 7" descr="capture.png"/>
           <p:cNvPicPr>
             <a:picLocks noChangeAspect="1"/>
           </p:cNvPicPr>
@@ -7279,8 +7279,8 @@
         </p:blipFill>
         <p:spPr>
           <a:xfrm>
-            <a:off x="621807" y="2145792"/>
-            <a:ext cx="6226968" cy="2999306"/>
+            <a:off x="402346" y="2194560"/>
+            <a:ext cx="3571283" cy="2999306"/>
           </a:xfrm>
           <a:prstGeom prst="rect">
             <a:avLst/>
@@ -7295,14 +7295,14 @@
         </p:nvSpPr>
         <p:spPr>
           <a:xfrm>
-            <a:off x="438922" y="6339840"/>
-            <a:ext cx="8873559" cy="487680"/>
+            <a:off x="4791575" y="2243328"/>
+            <a:ext cx="4535537" cy="1170432"/>
           </a:xfrm>
           <a:prstGeom prst="rect">
             <a:avLst/>
           </a:prstGeom>
           <a:solidFill>
-            <a:srgbClr val="152130"/>
+            <a:srgbClr val="F6F7F9"/>
           </a:solidFill>
           <a:ln>
             <a:noFill/>
@@ -7339,8 +7339,8 @@
         </p:nvSpPr>
         <p:spPr>
           <a:xfrm>
-            <a:off x="570599" y="6339840"/>
-            <a:ext cx="8632151" cy="487680"/>
+            <a:off x="4952514" y="2360371"/>
+            <a:ext cx="4213660" cy="243840"/>
           </a:xfrm>
           <a:prstGeom prst="rect">
             <a:avLst/>
@@ -7348,7 +7348,7 @@
           <a:noFill/>
         </p:spPr>
         <p:txBody>
-          <a:bodyPr wrap="square" anchor="ctr" lIns="0" rIns="0" tIns="0" bIns="0">
+          <a:bodyPr wrap="square" anchor="t" lIns="0" rIns="0" tIns="0" bIns="0">
             <a:spAutoFit/>
           </a:bodyPr>
           <a:lstStyle/>
@@ -7362,13 +7362,13 @@
               </a:spcAft>
             </a:pPr>
             <a:r>
-              <a:rPr sz="960" b="0" i="1">
-                <a:solidFill>
-                  <a:srgbClr val="FFFFFF"/>
+              <a:rPr sz="840" b="1" i="0">
+                <a:solidFill>
+                  <a:srgbClr val="314359"/>
                 </a:solidFill>
                 <a:latin typeface="Arial"/>
               </a:rPr>
-              <a:t>All Weather’s tight cone delivers the smoothest ride — but Athanase’s downside edge still clears All Weather’s and the market’s upside.</a:t>
+              <a:t>CAPTURE ASYMMETRY</a:t>
             </a:r>
           </a:p>
         </p:txBody>
@@ -7381,8 +7381,8 @@
         </p:nvSpPr>
         <p:spPr>
           <a:xfrm>
-            <a:off x="438922" y="6886041"/>
-            <a:ext cx="9217382" cy="438912"/>
+            <a:off x="4952514" y="2594457"/>
+            <a:ext cx="4213660" cy="341376"/>
           </a:xfrm>
           <a:prstGeom prst="rect">
             <a:avLst/>
@@ -7404,13 +7404,523 @@
               </a:spcAft>
             </a:pPr>
             <a:r>
-              <a:rPr sz="600" b="0" i="0">
-                <a:solidFill>
-                  <a:srgbClr val="556A83"/>
+              <a:rPr sz="1360" b="1" i="0">
+                <a:solidFill>
+                  <a:srgbClr val="314359"/>
+                </a:solidFill>
+                <a:latin typeface="Times New Roman"/>
+              </a:rPr>
+              <a:t>93% up  /  43% down</a:t>
+            </a:r>
+          </a:p>
+        </p:txBody>
+      </p:sp>
+      <p:sp>
+        <p:nvSpPr>
+          <p:cNvPr id="12" name="TextBox 11"/>
+          <p:cNvSpPr txBox="1"/>
+          <p:nvPr/>
+        </p:nvSpPr>
+        <p:spPr>
+          <a:xfrm>
+            <a:off x="4952514" y="2965094"/>
+            <a:ext cx="4213660" cy="438912"/>
+          </a:xfrm>
+          <a:prstGeom prst="rect">
+            <a:avLst/>
+          </a:prstGeom>
+          <a:noFill/>
+        </p:spPr>
+        <p:txBody>
+          <a:bodyPr wrap="square" anchor="t" lIns="0" rIns="0" tIns="0" bIns="0">
+            <a:spAutoFit/>
+          </a:bodyPr>
+          <a:lstStyle/>
+          <a:p>
+            <a:pPr algn="l">
+              <a:lnSpc>
+                <a:spcPct val="112000"/>
+              </a:lnSpc>
+              <a:spcAft>
+                <a:spcPts val="0"/>
+              </a:spcAft>
+            </a:pPr>
+            <a:r>
+              <a:rPr sz="840" b="0" i="0">
+                <a:solidFill>
+                  <a:srgbClr val="0E1620"/>
                 </a:solidFill>
                 <a:latin typeface="Arial"/>
               </a:rPr>
-              <a:t>Source: monthly net returns, 235 months (2006–2025), for MSCI and Athanase. *Bridgewater All Weather shown from public estimates (~7% return, ~6.5/7.0% up/downside deviation), not a supplied return series. Shaded band = expected ±1 annualised up/downside deviation, widening with √time. Illustrative; past performance ≠ future results.</a:t>
+              <a:t>Keeps pace with rallies but takes less than half of selloffs — the essence of the edge.</a:t>
+            </a:r>
+          </a:p>
+        </p:txBody>
+      </p:sp>
+      <p:sp>
+        <p:nvSpPr>
+          <p:cNvPr id="13" name="Rectangle 12"/>
+          <p:cNvSpPr/>
+          <p:nvPr/>
+        </p:nvSpPr>
+        <p:spPr>
+          <a:xfrm>
+            <a:off x="4791575" y="3530803"/>
+            <a:ext cx="4535537" cy="1170432"/>
+          </a:xfrm>
+          <a:prstGeom prst="rect">
+            <a:avLst/>
+          </a:prstGeom>
+          <a:solidFill>
+            <a:srgbClr val="F6F7F9"/>
+          </a:solidFill>
+          <a:ln>
+            <a:noFill/>
+          </a:ln>
+          <a:effectLst/>
+        </p:spPr>
+        <p:style>
+          <a:lnRef idx="1">
+            <a:schemeClr val="accent1"/>
+          </a:lnRef>
+          <a:fillRef idx="3">
+            <a:schemeClr val="accent1"/>
+          </a:fillRef>
+          <a:effectRef idx="2">
+            <a:schemeClr val="accent1"/>
+          </a:effectRef>
+          <a:fontRef idx="minor">
+            <a:schemeClr val="lt1"/>
+          </a:fontRef>
+        </p:style>
+        <p:txBody>
+          <a:bodyPr rtlCol="0" anchor="ctr"/>
+          <a:lstStyle/>
+          <a:p>
+            <a:pPr algn="ctr"/>
+          </a:p>
+        </p:txBody>
+      </p:sp>
+      <p:sp>
+        <p:nvSpPr>
+          <p:cNvPr id="14" name="TextBox 13"/>
+          <p:cNvSpPr txBox="1"/>
+          <p:nvPr/>
+        </p:nvSpPr>
+        <p:spPr>
+          <a:xfrm>
+            <a:off x="4952514" y="3647846"/>
+            <a:ext cx="4213660" cy="243840"/>
+          </a:xfrm>
+          <a:prstGeom prst="rect">
+            <a:avLst/>
+          </a:prstGeom>
+          <a:noFill/>
+        </p:spPr>
+        <p:txBody>
+          <a:bodyPr wrap="square" anchor="t" lIns="0" rIns="0" tIns="0" bIns="0">
+            <a:spAutoFit/>
+          </a:bodyPr>
+          <a:lstStyle/>
+          <a:p>
+            <a:pPr algn="l">
+              <a:lnSpc>
+                <a:spcPct val="110000"/>
+              </a:lnSpc>
+              <a:spcAft>
+                <a:spcPts val="0"/>
+              </a:spcAft>
+            </a:pPr>
+            <a:r>
+              <a:rPr sz="840" b="1" i="0">
+                <a:solidFill>
+                  <a:srgbClr val="314359"/>
+                </a:solidFill>
+                <a:latin typeface="Arial"/>
+              </a:rPr>
+              <a:t>DIVERSIFICATION</a:t>
+            </a:r>
+          </a:p>
+        </p:txBody>
+      </p:sp>
+      <p:sp>
+        <p:nvSpPr>
+          <p:cNvPr id="15" name="TextBox 14"/>
+          <p:cNvSpPr txBox="1"/>
+          <p:nvPr/>
+        </p:nvSpPr>
+        <p:spPr>
+          <a:xfrm>
+            <a:off x="4952514" y="3881932"/>
+            <a:ext cx="4213660" cy="341376"/>
+          </a:xfrm>
+          <a:prstGeom prst="rect">
+            <a:avLst/>
+          </a:prstGeom>
+          <a:noFill/>
+        </p:spPr>
+        <p:txBody>
+          <a:bodyPr wrap="square" anchor="t" lIns="0" rIns="0" tIns="0" bIns="0">
+            <a:spAutoFit/>
+          </a:bodyPr>
+          <a:lstStyle/>
+          <a:p>
+            <a:pPr algn="l">
+              <a:lnSpc>
+                <a:spcPct val="110000"/>
+              </a:lnSpc>
+              <a:spcAft>
+                <a:spcPts val="0"/>
+              </a:spcAft>
+            </a:pPr>
+            <a:r>
+              <a:rPr sz="1360" b="1" i="0">
+                <a:solidFill>
+                  <a:srgbClr val="314359"/>
+                </a:solidFill>
+                <a:latin typeface="Times New Roman"/>
+              </a:rPr>
+              <a:t>0.44 correlation  ·  0.73 beta</a:t>
+            </a:r>
+          </a:p>
+        </p:txBody>
+      </p:sp>
+      <p:sp>
+        <p:nvSpPr>
+          <p:cNvPr id="16" name="TextBox 15"/>
+          <p:cNvSpPr txBox="1"/>
+          <p:nvPr/>
+        </p:nvSpPr>
+        <p:spPr>
+          <a:xfrm>
+            <a:off x="4952514" y="4252569"/>
+            <a:ext cx="4213660" cy="438912"/>
+          </a:xfrm>
+          <a:prstGeom prst="rect">
+            <a:avLst/>
+          </a:prstGeom>
+          <a:noFill/>
+        </p:spPr>
+        <p:txBody>
+          <a:bodyPr wrap="square" anchor="t" lIns="0" rIns="0" tIns="0" bIns="0">
+            <a:spAutoFit/>
+          </a:bodyPr>
+          <a:lstStyle/>
+          <a:p>
+            <a:pPr algn="l">
+              <a:lnSpc>
+                <a:spcPct val="112000"/>
+              </a:lnSpc>
+              <a:spcAft>
+                <a:spcPts val="0"/>
+              </a:spcAft>
+            </a:pPr>
+            <a:r>
+              <a:rPr sz="840" b="0" i="0">
+                <a:solidFill>
+                  <a:srgbClr val="0E1620"/>
+                </a:solidFill>
+                <a:latin typeface="Arial"/>
+              </a:rPr>
+              <a:t>Low correlation to your existing equity book — a genuine diversifier, not levered beta.</a:t>
+            </a:r>
+          </a:p>
+        </p:txBody>
+      </p:sp>
+      <p:sp>
+        <p:nvSpPr>
+          <p:cNvPr id="17" name="Rectangle 16"/>
+          <p:cNvSpPr/>
+          <p:nvPr/>
+        </p:nvSpPr>
+        <p:spPr>
+          <a:xfrm>
+            <a:off x="4791575" y="4818278"/>
+            <a:ext cx="4535537" cy="1170432"/>
+          </a:xfrm>
+          <a:prstGeom prst="rect">
+            <a:avLst/>
+          </a:prstGeom>
+          <a:solidFill>
+            <a:srgbClr val="F6F7F9"/>
+          </a:solidFill>
+          <a:ln>
+            <a:noFill/>
+          </a:ln>
+          <a:effectLst/>
+        </p:spPr>
+        <p:style>
+          <a:lnRef idx="1">
+            <a:schemeClr val="accent1"/>
+          </a:lnRef>
+          <a:fillRef idx="3">
+            <a:schemeClr val="accent1"/>
+          </a:fillRef>
+          <a:effectRef idx="2">
+            <a:schemeClr val="accent1"/>
+          </a:effectRef>
+          <a:fontRef idx="minor">
+            <a:schemeClr val="lt1"/>
+          </a:fontRef>
+        </p:style>
+        <p:txBody>
+          <a:bodyPr rtlCol="0" anchor="ctr"/>
+          <a:lstStyle/>
+          <a:p>
+            <a:pPr algn="ctr"/>
+          </a:p>
+        </p:txBody>
+      </p:sp>
+      <p:sp>
+        <p:nvSpPr>
+          <p:cNvPr id="18" name="TextBox 17"/>
+          <p:cNvSpPr txBox="1"/>
+          <p:nvPr/>
+        </p:nvSpPr>
+        <p:spPr>
+          <a:xfrm>
+            <a:off x="4952514" y="4935321"/>
+            <a:ext cx="4213660" cy="243840"/>
+          </a:xfrm>
+          <a:prstGeom prst="rect">
+            <a:avLst/>
+          </a:prstGeom>
+          <a:noFill/>
+        </p:spPr>
+        <p:txBody>
+          <a:bodyPr wrap="square" anchor="t" lIns="0" rIns="0" tIns="0" bIns="0">
+            <a:spAutoFit/>
+          </a:bodyPr>
+          <a:lstStyle/>
+          <a:p>
+            <a:pPr algn="l">
+              <a:lnSpc>
+                <a:spcPct val="110000"/>
+              </a:lnSpc>
+              <a:spcAft>
+                <a:spcPts val="0"/>
+              </a:spcAft>
+            </a:pPr>
+            <a:r>
+              <a:rPr sz="840" b="1" i="0">
+                <a:solidFill>
+                  <a:srgbClr val="314359"/>
+                </a:solidFill>
+                <a:latin typeface="Arial"/>
+              </a:rPr>
+              <a:t>RELIABILITY OVER TIME</a:t>
+            </a:r>
+          </a:p>
+        </p:txBody>
+      </p:sp>
+      <p:sp>
+        <p:nvSpPr>
+          <p:cNvPr id="19" name="TextBox 18"/>
+          <p:cNvSpPr txBox="1"/>
+          <p:nvPr/>
+        </p:nvSpPr>
+        <p:spPr>
+          <a:xfrm>
+            <a:off x="4952514" y="5169408"/>
+            <a:ext cx="4213660" cy="341376"/>
+          </a:xfrm>
+          <a:prstGeom prst="rect">
+            <a:avLst/>
+          </a:prstGeom>
+          <a:noFill/>
+        </p:spPr>
+        <p:txBody>
+          <a:bodyPr wrap="square" anchor="t" lIns="0" rIns="0" tIns="0" bIns="0">
+            <a:spAutoFit/>
+          </a:bodyPr>
+          <a:lstStyle/>
+          <a:p>
+            <a:pPr algn="l">
+              <a:lnSpc>
+                <a:spcPct val="110000"/>
+              </a:lnSpc>
+              <a:spcAft>
+                <a:spcPts val="0"/>
+              </a:spcAft>
+            </a:pPr>
+            <a:r>
+              <a:rPr sz="1360" b="1" i="0">
+                <a:solidFill>
+                  <a:srgbClr val="314359"/>
+                </a:solidFill>
+                <a:latin typeface="Times New Roman"/>
+              </a:rPr>
+              <a:t>Beat MSCI in 90% of 5-yr and 100% of 7-yr windows</a:t>
+            </a:r>
+          </a:p>
+        </p:txBody>
+      </p:sp>
+      <p:sp>
+        <p:nvSpPr>
+          <p:cNvPr id="20" name="TextBox 19"/>
+          <p:cNvSpPr txBox="1"/>
+          <p:nvPr/>
+        </p:nvSpPr>
+        <p:spPr>
+          <a:xfrm>
+            <a:off x="4952514" y="5540044"/>
+            <a:ext cx="4213660" cy="438912"/>
+          </a:xfrm>
+          <a:prstGeom prst="rect">
+            <a:avLst/>
+          </a:prstGeom>
+          <a:noFill/>
+        </p:spPr>
+        <p:txBody>
+          <a:bodyPr wrap="square" anchor="t" lIns="0" rIns="0" tIns="0" bIns="0">
+            <a:spAutoFit/>
+          </a:bodyPr>
+          <a:lstStyle/>
+          <a:p>
+            <a:pPr algn="l">
+              <a:lnSpc>
+                <a:spcPct val="112000"/>
+              </a:lnSpc>
+              <a:spcAft>
+                <a:spcPts val="0"/>
+              </a:spcAft>
+            </a:pPr>
+            <a:r>
+              <a:rPr sz="840" b="0" i="0">
+                <a:solidFill>
+                  <a:srgbClr val="0E1620"/>
+                </a:solidFill>
+                <a:latin typeface="Arial"/>
+              </a:rPr>
+              <a:t>Over every rolling 7-year holding period in 20 years, Athanase out-returned the index.</a:t>
+            </a:r>
+          </a:p>
+        </p:txBody>
+      </p:sp>
+      <p:sp>
+        <p:nvSpPr>
+          <p:cNvPr id="21" name="Rectangle 20"/>
+          <p:cNvSpPr/>
+          <p:nvPr/>
+        </p:nvSpPr>
+        <p:spPr>
+          <a:xfrm>
+            <a:off x="438922" y="6456883"/>
+            <a:ext cx="8873559" cy="448665"/>
+          </a:xfrm>
+          <a:prstGeom prst="rect">
+            <a:avLst/>
+          </a:prstGeom>
+          <a:solidFill>
+            <a:srgbClr val="152130"/>
+          </a:solidFill>
+          <a:ln>
+            <a:noFill/>
+          </a:ln>
+          <a:effectLst/>
+        </p:spPr>
+        <p:style>
+          <a:lnRef idx="1">
+            <a:schemeClr val="accent1"/>
+          </a:lnRef>
+          <a:fillRef idx="3">
+            <a:schemeClr val="accent1"/>
+          </a:fillRef>
+          <a:effectRef idx="2">
+            <a:schemeClr val="accent1"/>
+          </a:effectRef>
+          <a:fontRef idx="minor">
+            <a:schemeClr val="lt1"/>
+          </a:fontRef>
+        </p:style>
+        <p:txBody>
+          <a:bodyPr rtlCol="0" anchor="ctr"/>
+          <a:lstStyle/>
+          <a:p>
+            <a:pPr algn="ctr"/>
+          </a:p>
+        </p:txBody>
+      </p:sp>
+      <p:sp>
+        <p:nvSpPr>
+          <p:cNvPr id="22" name="TextBox 21"/>
+          <p:cNvSpPr txBox="1"/>
+          <p:nvPr/>
+        </p:nvSpPr>
+        <p:spPr>
+          <a:xfrm>
+            <a:off x="570599" y="6456883"/>
+            <a:ext cx="8632151" cy="448665"/>
+          </a:xfrm>
+          <a:prstGeom prst="rect">
+            <a:avLst/>
+          </a:prstGeom>
+          <a:noFill/>
+        </p:spPr>
+        <p:txBody>
+          <a:bodyPr wrap="square" anchor="ctr" lIns="0" rIns="0" tIns="0" bIns="0">
+            <a:spAutoFit/>
+          </a:bodyPr>
+          <a:lstStyle/>
+          <a:p>
+            <a:pPr algn="l">
+              <a:lnSpc>
+                <a:spcPct val="110000"/>
+              </a:lnSpc>
+              <a:spcAft>
+                <a:spcPts val="0"/>
+              </a:spcAft>
+            </a:pPr>
+            <a:r>
+              <a:rPr sz="960" b="0" i="1">
+                <a:solidFill>
+                  <a:srgbClr val="FFFFFF"/>
+                </a:solidFill>
+                <a:latin typeface="Arial"/>
+              </a:rPr>
+              <a:t>Athanase captures 93% of the market’s upside but only 43% of its downside — at 0.44 correlation, it improves the whole portfolio, not just one line of it.</a:t>
+            </a:r>
+          </a:p>
+        </p:txBody>
+      </p:sp>
+      <p:sp>
+        <p:nvSpPr>
+          <p:cNvPr id="23" name="TextBox 22"/>
+          <p:cNvSpPr txBox="1"/>
+          <p:nvPr/>
+        </p:nvSpPr>
+        <p:spPr>
+          <a:xfrm>
+            <a:off x="438922" y="6983577"/>
+            <a:ext cx="9217382" cy="390144"/>
+          </a:xfrm>
+          <a:prstGeom prst="rect">
+            <a:avLst/>
+          </a:prstGeom>
+          <a:noFill/>
+        </p:spPr>
+        <p:txBody>
+          <a:bodyPr wrap="square" anchor="t" lIns="0" rIns="0" tIns="0" bIns="0">
+            <a:spAutoFit/>
+          </a:bodyPr>
+          <a:lstStyle/>
+          <a:p>
+            <a:pPr algn="l">
+              <a:lnSpc>
+                <a:spcPct val="110000"/>
+              </a:lnSpc>
+              <a:spcAft>
+                <a:spcPts val="0"/>
+              </a:spcAft>
+            </a:pPr>
+            <a:r>
+              <a:rPr sz="600" b="0" i="0">
+                <a:solidFill>
+                  <a:srgbClr val="556A83"/>
+                </a:solidFill>
+                <a:latin typeface="Arial"/>
+              </a:rPr>
+              <a:t>Source: monthly net returns, 235 months (2006–2025). Capture = compounded Athanase return in the market’s up/down months ÷ the market’s. Beta/correlation and rolling-window win rates from the same series. Past performance is not indicative of future results.</a:t>
             </a:r>
           </a:p>
         </p:txBody>

</xml_diff>

<commit_message>
Add efficient-frontier slide (blend return vs downside risk); fix slide-2 capture legend placement
</commit_message>
<xml_diff>
--- a/Athanase_Downside_Risk_Outcomes.pptx
+++ b/Athanase_Downside_Risk_Outcomes.pptx
@@ -7,6 +7,7 @@
   <p:sldIdLst>
     <p:sldId id="256" r:id="rId7"/>
     <p:sldId id="257" r:id="rId8"/>
+    <p:sldId id="258" r:id="rId9"/>
   </p:sldIdLst>
   <p:sldSz cx="9753600" cy="7315200" type="screen4x3"/>
   <p:notesSz cx="6858000" cy="9144000"/>
@@ -7280,7 +7281,7 @@
         <p:spPr>
           <a:xfrm>
             <a:off x="402346" y="2194560"/>
-            <a:ext cx="3571283" cy="2999306"/>
+            <a:ext cx="3627489" cy="2999306"/>
           </a:xfrm>
           <a:prstGeom prst="rect">
             <a:avLst/>
@@ -7921,6 +7922,806 @@
                 <a:latin typeface="Arial"/>
               </a:rPr>
               <a:t>Source: monthly net returns, 235 months (2006–2025). Capture = compounded Athanase return in the market’s up/down months ÷ the market’s. Beta/correlation and rolling-window win rates from the same series. Past performance is not indicative of future results.</a:t>
+            </a:r>
+          </a:p>
+        </p:txBody>
+      </p:sp>
+    </p:spTree>
+  </p:cSld>
+  <p:clrMapOvr>
+    <a:masterClrMapping/>
+  </p:clrMapOvr>
+</p:sld>
+</file>
+
+<file path=ppt/slides/slide3.xml><?xml version="1.0" encoding="utf-8"?>
+<p:sld xmlns:a="http://schemas.openxmlformats.org/drawingml/2006/main" xmlns:p="http://schemas.openxmlformats.org/presentationml/2006/main" xmlns:r="http://schemas.openxmlformats.org/officeDocument/2006/relationships">
+  <p:cSld>
+    <p:spTree>
+      <p:nvGrpSpPr>
+        <p:cNvPr id="1" name=""/>
+        <p:cNvGrpSpPr/>
+        <p:nvPr/>
+      </p:nvGrpSpPr>
+      <p:grpSpPr/>
+      <p:pic>
+        <p:nvPicPr>
+          <p:cNvPr id="2" name="Picture 1" descr="mark_dark.png"/>
+          <p:cNvPicPr>
+            <a:picLocks noChangeAspect="1"/>
+          </p:cNvPicPr>
+          <p:nvPr/>
+        </p:nvPicPr>
+        <p:blipFill>
+          <a:blip r:embed="rId2"/>
+          <a:stretch>
+            <a:fillRect/>
+          </a:stretch>
+        </p:blipFill>
+        <p:spPr>
+          <a:xfrm>
+            <a:off x="402346" y="234086"/>
+            <a:ext cx="224012" cy="190199"/>
+          </a:xfrm>
+          <a:prstGeom prst="rect">
+            <a:avLst/>
+          </a:prstGeom>
+        </p:spPr>
+      </p:pic>
+      <p:sp>
+        <p:nvSpPr>
+          <p:cNvPr id="3" name="TextBox 2"/>
+          <p:cNvSpPr txBox="1"/>
+          <p:nvPr/>
+        </p:nvSpPr>
+        <p:spPr>
+          <a:xfrm>
+            <a:off x="716907" y="263347"/>
+            <a:ext cx="5120768" cy="292608"/>
+          </a:xfrm>
+          <a:prstGeom prst="rect">
+            <a:avLst/>
+          </a:prstGeom>
+          <a:noFill/>
+        </p:spPr>
+        <p:txBody>
+          <a:bodyPr wrap="square" anchor="t" lIns="0" rIns="0" tIns="0" bIns="0">
+            <a:spAutoFit/>
+          </a:bodyPr>
+          <a:lstStyle/>
+          <a:p>
+            <a:pPr algn="l">
+              <a:lnSpc>
+                <a:spcPct val="110000"/>
+              </a:lnSpc>
+              <a:spcAft>
+                <a:spcPts val="0"/>
+              </a:spcAft>
+            </a:pPr>
+            <a:r>
+              <a:rPr sz="880" b="0" i="0">
+                <a:solidFill>
+                  <a:srgbClr val="556A83"/>
+                </a:solidFill>
+                <a:latin typeface="Arial"/>
+              </a:rPr>
+              <a:t>Risk-Adjusted Outcomes</a:t>
+            </a:r>
+          </a:p>
+        </p:txBody>
+      </p:sp>
+      <p:sp>
+        <p:nvSpPr>
+          <p:cNvPr id="4" name="TextBox 3"/>
+          <p:cNvSpPr txBox="1"/>
+          <p:nvPr/>
+        </p:nvSpPr>
+        <p:spPr>
+          <a:xfrm>
+            <a:off x="7242229" y="263347"/>
+            <a:ext cx="2084884" cy="292608"/>
+          </a:xfrm>
+          <a:prstGeom prst="rect">
+            <a:avLst/>
+          </a:prstGeom>
+          <a:noFill/>
+        </p:spPr>
+        <p:txBody>
+          <a:bodyPr wrap="square" anchor="t" lIns="0" rIns="0" tIns="0" bIns="0">
+            <a:spAutoFit/>
+          </a:bodyPr>
+          <a:lstStyle/>
+          <a:p>
+            <a:pPr algn="r">
+              <a:lnSpc>
+                <a:spcPct val="110000"/>
+              </a:lnSpc>
+              <a:spcAft>
+                <a:spcPts val="0"/>
+              </a:spcAft>
+            </a:pPr>
+            <a:r>
+              <a:rPr sz="880" b="1" i="0">
+                <a:solidFill>
+                  <a:srgbClr val="556A83"/>
+                </a:solidFill>
+                <a:latin typeface="Arial"/>
+              </a:rPr>
+              <a:t>Figure 3</a:t>
+            </a:r>
+          </a:p>
+        </p:txBody>
+      </p:sp>
+      <p:sp>
+        <p:nvSpPr>
+          <p:cNvPr id="5" name="Rectangle 4"/>
+          <p:cNvSpPr/>
+          <p:nvPr/>
+        </p:nvSpPr>
+        <p:spPr>
+          <a:xfrm>
+            <a:off x="0" y="604723"/>
+            <a:ext cx="9753600" cy="1414272"/>
+          </a:xfrm>
+          <a:prstGeom prst="rect">
+            <a:avLst/>
+          </a:prstGeom>
+          <a:solidFill>
+            <a:srgbClr val="F6F7F9"/>
+          </a:solidFill>
+          <a:ln>
+            <a:noFill/>
+          </a:ln>
+          <a:effectLst/>
+        </p:spPr>
+        <p:style>
+          <a:lnRef idx="1">
+            <a:schemeClr val="accent1"/>
+          </a:lnRef>
+          <a:fillRef idx="3">
+            <a:schemeClr val="accent1"/>
+          </a:fillRef>
+          <a:effectRef idx="2">
+            <a:schemeClr val="accent1"/>
+          </a:effectRef>
+          <a:fontRef idx="minor">
+            <a:schemeClr val="lt1"/>
+          </a:fontRef>
+        </p:style>
+        <p:txBody>
+          <a:bodyPr rtlCol="0" anchor="ctr"/>
+          <a:lstStyle/>
+          <a:p>
+            <a:pPr algn="ctr"/>
+          </a:p>
+        </p:txBody>
+      </p:sp>
+      <p:sp>
+        <p:nvSpPr>
+          <p:cNvPr id="6" name="TextBox 5"/>
+          <p:cNvSpPr txBox="1"/>
+          <p:nvPr/>
+        </p:nvSpPr>
+        <p:spPr>
+          <a:xfrm>
+            <a:off x="438922" y="721766"/>
+            <a:ext cx="8851613" cy="829056"/>
+          </a:xfrm>
+          <a:prstGeom prst="rect">
+            <a:avLst/>
+          </a:prstGeom>
+          <a:noFill/>
+        </p:spPr>
+        <p:txBody>
+          <a:bodyPr wrap="square" anchor="t" lIns="0" rIns="0" tIns="0" bIns="0">
+            <a:spAutoFit/>
+          </a:bodyPr>
+          <a:lstStyle/>
+          <a:p>
+            <a:pPr algn="l">
+              <a:lnSpc>
+                <a:spcPct val="110000"/>
+              </a:lnSpc>
+              <a:spcAft>
+                <a:spcPts val="200"/>
+              </a:spcAft>
+            </a:pPr>
+            <a:r>
+              <a:rPr sz="2400" b="0" i="0" spc="-90">
+                <a:solidFill>
+                  <a:srgbClr val="314359"/>
+                </a:solidFill>
+                <a:latin typeface="Times New Roman"/>
+              </a:rPr>
+              <a:t>What a blend does to the whole portfolio</a:t>
+            </a:r>
+          </a:p>
+        </p:txBody>
+      </p:sp>
+      <p:sp>
+        <p:nvSpPr>
+          <p:cNvPr id="7" name="TextBox 6"/>
+          <p:cNvSpPr txBox="1"/>
+          <p:nvPr/>
+        </p:nvSpPr>
+        <p:spPr>
+          <a:xfrm>
+            <a:off x="453553" y="1511808"/>
+            <a:ext cx="8705305" cy="487680"/>
+          </a:xfrm>
+          <a:prstGeom prst="rect">
+            <a:avLst/>
+          </a:prstGeom>
+          <a:noFill/>
+        </p:spPr>
+        <p:txBody>
+          <a:bodyPr wrap="square" anchor="t" lIns="0" rIns="0" tIns="0" bIns="0">
+            <a:spAutoFit/>
+          </a:bodyPr>
+          <a:lstStyle/>
+          <a:p>
+            <a:pPr algn="l">
+              <a:lnSpc>
+                <a:spcPct val="110000"/>
+              </a:lnSpc>
+              <a:spcAft>
+                <a:spcPts val="0"/>
+              </a:spcAft>
+            </a:pPr>
+            <a:r>
+              <a:rPr sz="1040" b="0" i="1">
+                <a:solidFill>
+                  <a:srgbClr val="556A83"/>
+                </a:solidFill>
+                <a:latin typeface="Arial"/>
+              </a:rPr>
+              <a:t>Adding Athanase to a global-equity book moves the portfolio up and to the left — more return for less downside risk, thanks to low correlation.</a:t>
+            </a:r>
+          </a:p>
+        </p:txBody>
+      </p:sp>
+      <p:pic>
+        <p:nvPicPr>
+          <p:cNvPr id="8" name="Picture 7" descr="frontier.png"/>
+          <p:cNvPicPr>
+            <a:picLocks noChangeAspect="1"/>
+          </p:cNvPicPr>
+          <p:nvPr/>
+        </p:nvPicPr>
+        <p:blipFill>
+          <a:blip r:embed="rId3"/>
+          <a:stretch>
+            <a:fillRect/>
+          </a:stretch>
+        </p:blipFill>
+        <p:spPr>
+          <a:xfrm>
+            <a:off x="402346" y="2194560"/>
+            <a:ext cx="6002145" cy="2999306"/>
+          </a:xfrm>
+          <a:prstGeom prst="rect">
+            <a:avLst/>
+          </a:prstGeom>
+        </p:spPr>
+      </p:pic>
+      <p:sp>
+        <p:nvSpPr>
+          <p:cNvPr id="9" name="Rectangle 8"/>
+          <p:cNvSpPr/>
+          <p:nvPr/>
+        </p:nvSpPr>
+        <p:spPr>
+          <a:xfrm>
+            <a:off x="6510690" y="2292096"/>
+            <a:ext cx="2816422" cy="1219200"/>
+          </a:xfrm>
+          <a:prstGeom prst="rect">
+            <a:avLst/>
+          </a:prstGeom>
+          <a:solidFill>
+            <a:srgbClr val="F6F7F9"/>
+          </a:solidFill>
+          <a:ln>
+            <a:noFill/>
+          </a:ln>
+          <a:effectLst/>
+        </p:spPr>
+        <p:style>
+          <a:lnRef idx="1">
+            <a:schemeClr val="accent1"/>
+          </a:lnRef>
+          <a:fillRef idx="3">
+            <a:schemeClr val="accent1"/>
+          </a:fillRef>
+          <a:effectRef idx="2">
+            <a:schemeClr val="accent1"/>
+          </a:effectRef>
+          <a:fontRef idx="minor">
+            <a:schemeClr val="lt1"/>
+          </a:fontRef>
+        </p:style>
+        <p:txBody>
+          <a:bodyPr rtlCol="0" anchor="ctr"/>
+          <a:lstStyle/>
+          <a:p>
+            <a:pPr algn="ctr"/>
+          </a:p>
+        </p:txBody>
+      </p:sp>
+      <p:sp>
+        <p:nvSpPr>
+          <p:cNvPr id="10" name="TextBox 9"/>
+          <p:cNvSpPr txBox="1"/>
+          <p:nvPr/>
+        </p:nvSpPr>
+        <p:spPr>
+          <a:xfrm>
+            <a:off x="6671629" y="2409139"/>
+            <a:ext cx="2494545" cy="243840"/>
+          </a:xfrm>
+          <a:prstGeom prst="rect">
+            <a:avLst/>
+          </a:prstGeom>
+          <a:noFill/>
+        </p:spPr>
+        <p:txBody>
+          <a:bodyPr wrap="square" anchor="t" lIns="0" rIns="0" tIns="0" bIns="0">
+            <a:spAutoFit/>
+          </a:bodyPr>
+          <a:lstStyle/>
+          <a:p>
+            <a:pPr algn="l">
+              <a:lnSpc>
+                <a:spcPct val="110000"/>
+              </a:lnSpc>
+              <a:spcAft>
+                <a:spcPts val="0"/>
+              </a:spcAft>
+            </a:pPr>
+            <a:r>
+              <a:rPr sz="840" b="1" i="0">
+                <a:solidFill>
+                  <a:srgbClr val="314359"/>
+                </a:solidFill>
+                <a:latin typeface="Arial"/>
+              </a:rPr>
+              <a:t>ALL GLOBAL EQUITIES</a:t>
+            </a:r>
+          </a:p>
+        </p:txBody>
+      </p:sp>
+      <p:sp>
+        <p:nvSpPr>
+          <p:cNvPr id="11" name="TextBox 10"/>
+          <p:cNvSpPr txBox="1"/>
+          <p:nvPr/>
+        </p:nvSpPr>
+        <p:spPr>
+          <a:xfrm>
+            <a:off x="6671629" y="2682240"/>
+            <a:ext cx="2494545" cy="438912"/>
+          </a:xfrm>
+          <a:prstGeom prst="rect">
+            <a:avLst/>
+          </a:prstGeom>
+          <a:noFill/>
+        </p:spPr>
+        <p:txBody>
+          <a:bodyPr wrap="square" anchor="t" lIns="0" rIns="0" tIns="0" bIns="0">
+            <a:spAutoFit/>
+          </a:bodyPr>
+          <a:lstStyle/>
+          <a:p>
+            <a:pPr>
+              <a:spcAft>
+                <a:spcPts val="0"/>
+              </a:spcAft>
+            </a:pPr>
+            <a:r>
+              <a:rPr sz="1360" b="1">
+                <a:solidFill>
+                  <a:srgbClr val="314359"/>
+                </a:solidFill>
+                <a:latin typeface="Times New Roman"/>
+              </a:rPr>
+              <a:t>6.1% return</a:t>
+            </a:r>
+            <a:r>
+              <a:rPr sz="1040">
+                <a:solidFill>
+                  <a:srgbClr val="314359"/>
+                </a:solidFill>
+                <a:latin typeface="Arial"/>
+              </a:rPr>
+              <a:t>   ·   11.5% downside risk</a:t>
+            </a:r>
+          </a:p>
+        </p:txBody>
+      </p:sp>
+      <p:sp>
+        <p:nvSpPr>
+          <p:cNvPr id="12" name="TextBox 11"/>
+          <p:cNvSpPr txBox="1"/>
+          <p:nvPr/>
+        </p:nvSpPr>
+        <p:spPr>
+          <a:xfrm>
+            <a:off x="6671629" y="3130905"/>
+            <a:ext cx="2494545" cy="292608"/>
+          </a:xfrm>
+          <a:prstGeom prst="rect">
+            <a:avLst/>
+          </a:prstGeom>
+          <a:noFill/>
+        </p:spPr>
+        <p:txBody>
+          <a:bodyPr wrap="square" anchor="t" lIns="0" rIns="0" tIns="0" bIns="0">
+            <a:spAutoFit/>
+          </a:bodyPr>
+          <a:lstStyle/>
+          <a:p>
+            <a:pPr algn="l">
+              <a:lnSpc>
+                <a:spcPct val="110000"/>
+              </a:lnSpc>
+              <a:spcAft>
+                <a:spcPts val="0"/>
+              </a:spcAft>
+            </a:pPr>
+            <a:r>
+              <a:rPr sz="840" b="0" i="0">
+                <a:solidFill>
+                  <a:srgbClr val="0E1620"/>
+                </a:solidFill>
+                <a:latin typeface="Arial"/>
+              </a:rPr>
+              <a:t>100% MSCI World IMI</a:t>
+            </a:r>
+          </a:p>
+        </p:txBody>
+      </p:sp>
+      <p:sp>
+        <p:nvSpPr>
+          <p:cNvPr id="13" name="Rectangle 12"/>
+          <p:cNvSpPr/>
+          <p:nvPr/>
+        </p:nvSpPr>
+        <p:spPr>
+          <a:xfrm>
+            <a:off x="6510690" y="3686860"/>
+            <a:ext cx="2816422" cy="1219200"/>
+          </a:xfrm>
+          <a:prstGeom prst="rect">
+            <a:avLst/>
+          </a:prstGeom>
+          <a:solidFill>
+            <a:srgbClr val="F6F7F9"/>
+          </a:solidFill>
+          <a:ln>
+            <a:noFill/>
+          </a:ln>
+          <a:effectLst/>
+        </p:spPr>
+        <p:style>
+          <a:lnRef idx="1">
+            <a:schemeClr val="accent1"/>
+          </a:lnRef>
+          <a:fillRef idx="3">
+            <a:schemeClr val="accent1"/>
+          </a:fillRef>
+          <a:effectRef idx="2">
+            <a:schemeClr val="accent1"/>
+          </a:effectRef>
+          <a:fontRef idx="minor">
+            <a:schemeClr val="lt1"/>
+          </a:fontRef>
+        </p:style>
+        <p:txBody>
+          <a:bodyPr rtlCol="0" anchor="ctr"/>
+          <a:lstStyle/>
+          <a:p>
+            <a:pPr algn="ctr"/>
+          </a:p>
+        </p:txBody>
+      </p:sp>
+      <p:sp>
+        <p:nvSpPr>
+          <p:cNvPr id="14" name="TextBox 13"/>
+          <p:cNvSpPr txBox="1"/>
+          <p:nvPr/>
+        </p:nvSpPr>
+        <p:spPr>
+          <a:xfrm>
+            <a:off x="6671629" y="3803904"/>
+            <a:ext cx="2494545" cy="243840"/>
+          </a:xfrm>
+          <a:prstGeom prst="rect">
+            <a:avLst/>
+          </a:prstGeom>
+          <a:noFill/>
+        </p:spPr>
+        <p:txBody>
+          <a:bodyPr wrap="square" anchor="t" lIns="0" rIns="0" tIns="0" bIns="0">
+            <a:spAutoFit/>
+          </a:bodyPr>
+          <a:lstStyle/>
+          <a:p>
+            <a:pPr algn="l">
+              <a:lnSpc>
+                <a:spcPct val="110000"/>
+              </a:lnSpc>
+              <a:spcAft>
+                <a:spcPts val="0"/>
+              </a:spcAft>
+            </a:pPr>
+            <a:r>
+              <a:rPr sz="840" b="1" i="0">
+                <a:solidFill>
+                  <a:srgbClr val="314359"/>
+                </a:solidFill>
+                <a:latin typeface="Arial"/>
+              </a:rPr>
+              <a:t>ADD A 30% SLEEVE</a:t>
+            </a:r>
+          </a:p>
+        </p:txBody>
+      </p:sp>
+      <p:sp>
+        <p:nvSpPr>
+          <p:cNvPr id="15" name="TextBox 14"/>
+          <p:cNvSpPr txBox="1"/>
+          <p:nvPr/>
+        </p:nvSpPr>
+        <p:spPr>
+          <a:xfrm>
+            <a:off x="6671629" y="4077004"/>
+            <a:ext cx="2494545" cy="438912"/>
+          </a:xfrm>
+          <a:prstGeom prst="rect">
+            <a:avLst/>
+          </a:prstGeom>
+          <a:noFill/>
+        </p:spPr>
+        <p:txBody>
+          <a:bodyPr wrap="square" anchor="t" lIns="0" rIns="0" tIns="0" bIns="0">
+            <a:spAutoFit/>
+          </a:bodyPr>
+          <a:lstStyle/>
+          <a:p>
+            <a:pPr>
+              <a:spcAft>
+                <a:spcPts val="0"/>
+              </a:spcAft>
+            </a:pPr>
+            <a:r>
+              <a:rPr sz="1360" b="1">
+                <a:solidFill>
+                  <a:srgbClr val="314359"/>
+                </a:solidFill>
+                <a:latin typeface="Times New Roman"/>
+              </a:rPr>
+              <a:t>9.5% return</a:t>
+            </a:r>
+            <a:r>
+              <a:rPr sz="1040">
+                <a:solidFill>
+                  <a:srgbClr val="314359"/>
+                </a:solidFill>
+                <a:latin typeface="Arial"/>
+              </a:rPr>
+              <a:t>   ·   10.5% downside risk</a:t>
+            </a:r>
+          </a:p>
+        </p:txBody>
+      </p:sp>
+      <p:sp>
+        <p:nvSpPr>
+          <p:cNvPr id="16" name="TextBox 15"/>
+          <p:cNvSpPr txBox="1"/>
+          <p:nvPr/>
+        </p:nvSpPr>
+        <p:spPr>
+          <a:xfrm>
+            <a:off x="6671629" y="4525670"/>
+            <a:ext cx="2494545" cy="292608"/>
+          </a:xfrm>
+          <a:prstGeom prst="rect">
+            <a:avLst/>
+          </a:prstGeom>
+          <a:noFill/>
+        </p:spPr>
+        <p:txBody>
+          <a:bodyPr wrap="square" anchor="t" lIns="0" rIns="0" tIns="0" bIns="0">
+            <a:spAutoFit/>
+          </a:bodyPr>
+          <a:lstStyle/>
+          <a:p>
+            <a:pPr algn="l">
+              <a:lnSpc>
+                <a:spcPct val="110000"/>
+              </a:lnSpc>
+              <a:spcAft>
+                <a:spcPts val="0"/>
+              </a:spcAft>
+            </a:pPr>
+            <a:r>
+              <a:rPr sz="840" b="0" i="0">
+                <a:solidFill>
+                  <a:srgbClr val="0E1620"/>
+                </a:solidFill>
+                <a:latin typeface="Arial"/>
+              </a:rPr>
+              <a:t>70% MSCI  /  30% Athanase</a:t>
+            </a:r>
+          </a:p>
+        </p:txBody>
+      </p:sp>
+      <p:sp>
+        <p:nvSpPr>
+          <p:cNvPr id="17" name="TextBox 16"/>
+          <p:cNvSpPr txBox="1"/>
+          <p:nvPr/>
+        </p:nvSpPr>
+        <p:spPr>
+          <a:xfrm>
+            <a:off x="6510690" y="5081625"/>
+            <a:ext cx="2816422" cy="780288"/>
+          </a:xfrm>
+          <a:prstGeom prst="rect">
+            <a:avLst/>
+          </a:prstGeom>
+          <a:noFill/>
+        </p:spPr>
+        <p:txBody>
+          <a:bodyPr wrap="square" anchor="t" lIns="0" rIns="0" tIns="0" bIns="0">
+            <a:spAutoFit/>
+          </a:bodyPr>
+          <a:lstStyle/>
+          <a:p>
+            <a:pPr algn="l">
+              <a:lnSpc>
+                <a:spcPct val="120000"/>
+              </a:lnSpc>
+              <a:spcAft>
+                <a:spcPts val="0"/>
+              </a:spcAft>
+            </a:pPr>
+            <a:r>
+              <a:rPr sz="960" b="1" i="0">
+                <a:solidFill>
+                  <a:srgbClr val="152130"/>
+                </a:solidFill>
+                <a:latin typeface="Arial"/>
+              </a:rPr>
+              <a:t>+3.4 pts of return while downside risk FALLS by 1.0 pts.</a:t>
+            </a:r>
+          </a:p>
+        </p:txBody>
+      </p:sp>
+      <p:sp>
+        <p:nvSpPr>
+          <p:cNvPr id="18" name="Rectangle 17"/>
+          <p:cNvSpPr/>
+          <p:nvPr/>
+        </p:nvSpPr>
+        <p:spPr>
+          <a:xfrm>
+            <a:off x="438922" y="6456883"/>
+            <a:ext cx="8873559" cy="448665"/>
+          </a:xfrm>
+          <a:prstGeom prst="rect">
+            <a:avLst/>
+          </a:prstGeom>
+          <a:solidFill>
+            <a:srgbClr val="152130"/>
+          </a:solidFill>
+          <a:ln>
+            <a:noFill/>
+          </a:ln>
+          <a:effectLst/>
+        </p:spPr>
+        <p:style>
+          <a:lnRef idx="1">
+            <a:schemeClr val="accent1"/>
+          </a:lnRef>
+          <a:fillRef idx="3">
+            <a:schemeClr val="accent1"/>
+          </a:fillRef>
+          <a:effectRef idx="2">
+            <a:schemeClr val="accent1"/>
+          </a:effectRef>
+          <a:fontRef idx="minor">
+            <a:schemeClr val="lt1"/>
+          </a:fontRef>
+        </p:style>
+        <p:txBody>
+          <a:bodyPr rtlCol="0" anchor="ctr"/>
+          <a:lstStyle/>
+          <a:p>
+            <a:pPr algn="ctr"/>
+          </a:p>
+        </p:txBody>
+      </p:sp>
+      <p:sp>
+        <p:nvSpPr>
+          <p:cNvPr id="19" name="TextBox 18"/>
+          <p:cNvSpPr txBox="1"/>
+          <p:nvPr/>
+        </p:nvSpPr>
+        <p:spPr>
+          <a:xfrm>
+            <a:off x="570599" y="6456883"/>
+            <a:ext cx="8632151" cy="448665"/>
+          </a:xfrm>
+          <a:prstGeom prst="rect">
+            <a:avLst/>
+          </a:prstGeom>
+          <a:noFill/>
+        </p:spPr>
+        <p:txBody>
+          <a:bodyPr wrap="square" anchor="ctr" lIns="0" rIns="0" tIns="0" bIns="0">
+            <a:spAutoFit/>
+          </a:bodyPr>
+          <a:lstStyle/>
+          <a:p>
+            <a:pPr algn="l">
+              <a:lnSpc>
+                <a:spcPct val="110000"/>
+              </a:lnSpc>
+              <a:spcAft>
+                <a:spcPts val="0"/>
+              </a:spcAft>
+            </a:pPr>
+            <a:r>
+              <a:rPr sz="960" b="0" i="1">
+                <a:solidFill>
+                  <a:srgbClr val="FFFFFF"/>
+                </a:solidFill>
+                <a:latin typeface="Arial"/>
+              </a:rPr>
+              <a:t>The blend is not a trade-off — a 30% sleeve raises return AND lowers downside risk versus holding global equities alone.</a:t>
+            </a:r>
+          </a:p>
+        </p:txBody>
+      </p:sp>
+      <p:sp>
+        <p:nvSpPr>
+          <p:cNvPr id="20" name="TextBox 19"/>
+          <p:cNvSpPr txBox="1"/>
+          <p:nvPr/>
+        </p:nvSpPr>
+        <p:spPr>
+          <a:xfrm>
+            <a:off x="438922" y="6983577"/>
+            <a:ext cx="9217382" cy="390144"/>
+          </a:xfrm>
+          <a:prstGeom prst="rect">
+            <a:avLst/>
+          </a:prstGeom>
+          <a:noFill/>
+        </p:spPr>
+        <p:txBody>
+          <a:bodyPr wrap="square" anchor="t" lIns="0" rIns="0" tIns="0" bIns="0">
+            <a:spAutoFit/>
+          </a:bodyPr>
+          <a:lstStyle/>
+          <a:p>
+            <a:pPr algn="l">
+              <a:lnSpc>
+                <a:spcPct val="110000"/>
+              </a:lnSpc>
+              <a:spcAft>
+                <a:spcPts val="0"/>
+              </a:spcAft>
+            </a:pPr>
+            <a:r>
+              <a:rPr sz="600" b="0" i="0">
+                <a:solidFill>
+                  <a:srgbClr val="556A83"/>
+                </a:solidFill>
+                <a:latin typeface="Arial"/>
+              </a:rPr>
+              <a:t>Source: monthly net returns, 235 months (2006–2025), monthly rebalanced blends. Downside volatility = annualised deviation of negative months (MAR 0). Illustrative; past performance is not indicative of future results.</a:t>
             </a:r>
           </a:p>
         </p:txBody>

</xml_diff>

<commit_message>
Frontier: mark minimum-downside-risk point (~60%) and prudent 3-8% zone; add directional-argument caption with prudence caveat
</commit_message>
<xml_diff>
--- a/Athanase_Downside_Risk_Outcomes.pptx
+++ b/Athanase_Downside_Risk_Outcomes.pptx
@@ -8212,8 +8212,8 @@
         </p:nvSpPr>
         <p:spPr>
           <a:xfrm>
-            <a:off x="6510690" y="2292096"/>
-            <a:ext cx="2816422" cy="1219200"/>
+            <a:off x="6510690" y="2262835"/>
+            <a:ext cx="2816422" cy="1170432"/>
           </a:xfrm>
           <a:prstGeom prst="rect">
             <a:avLst/>
@@ -8256,7 +8256,7 @@
         </p:nvSpPr>
         <p:spPr>
           <a:xfrm>
-            <a:off x="6671629" y="2409139"/>
+            <a:off x="6671629" y="2379878"/>
             <a:ext cx="2494545" cy="243840"/>
           </a:xfrm>
           <a:prstGeom prst="rect">
@@ -8298,7 +8298,7 @@
         </p:nvSpPr>
         <p:spPr>
           <a:xfrm>
-            <a:off x="6671629" y="2682240"/>
+            <a:off x="6671629" y="2633472"/>
             <a:ext cx="2494545" cy="438912"/>
           </a:xfrm>
           <a:prstGeom prst="rect">
@@ -8318,7 +8318,7 @@
               </a:spcAft>
             </a:pPr>
             <a:r>
-              <a:rPr sz="1360" b="1">
+              <a:rPr sz="1280" b="1">
                 <a:solidFill>
                   <a:srgbClr val="314359"/>
                 </a:solidFill>
@@ -8327,7 +8327,7 @@
               <a:t>6.1% return</a:t>
             </a:r>
             <a:r>
-              <a:rPr sz="1040">
+              <a:rPr sz="960">
                 <a:solidFill>
                   <a:srgbClr val="314359"/>
                 </a:solidFill>
@@ -8346,7 +8346,7 @@
         </p:nvSpPr>
         <p:spPr>
           <a:xfrm>
-            <a:off x="6671629" y="3130905"/>
+            <a:off x="6671629" y="3062630"/>
             <a:ext cx="2494545" cy="292608"/>
           </a:xfrm>
           <a:prstGeom prst="rect">
@@ -8388,8 +8388,8 @@
         </p:nvSpPr>
         <p:spPr>
           <a:xfrm>
-            <a:off x="6510690" y="3686860"/>
-            <a:ext cx="2816422" cy="1219200"/>
+            <a:off x="6510690" y="3569817"/>
+            <a:ext cx="2816422" cy="1170432"/>
           </a:xfrm>
           <a:prstGeom prst="rect">
             <a:avLst/>
@@ -8432,7 +8432,7 @@
         </p:nvSpPr>
         <p:spPr>
           <a:xfrm>
-            <a:off x="6671629" y="3803904"/>
+            <a:off x="6671629" y="3686860"/>
             <a:ext cx="2494545" cy="243840"/>
           </a:xfrm>
           <a:prstGeom prst="rect">
@@ -8461,7 +8461,7 @@
                 </a:solidFill>
                 <a:latin typeface="Arial"/>
               </a:rPr>
-              <a:t>ADD A 30% SLEEVE</a:t>
+              <a:t>ADD A PRUDENT 8% SLEEVE</a:t>
             </a:r>
           </a:p>
         </p:txBody>
@@ -8474,7 +8474,7 @@
         </p:nvSpPr>
         <p:spPr>
           <a:xfrm>
-            <a:off x="6671629" y="4077004"/>
+            <a:off x="6671629" y="3940454"/>
             <a:ext cx="2494545" cy="438912"/>
           </a:xfrm>
           <a:prstGeom prst="rect">
@@ -8494,22 +8494,22 @@
               </a:spcAft>
             </a:pPr>
             <a:r>
-              <a:rPr sz="1360" b="1">
+              <a:rPr sz="1280" b="1">
                 <a:solidFill>
                   <a:srgbClr val="314359"/>
                 </a:solidFill>
                 <a:latin typeface="Times New Roman"/>
               </a:rPr>
-              <a:t>9.5% return</a:t>
-            </a:r>
-            <a:r>
-              <a:rPr sz="1040">
+              <a:t>7.3% return</a:t>
+            </a:r>
+            <a:r>
+              <a:rPr sz="960">
                 <a:solidFill>
                   <a:srgbClr val="314359"/>
                 </a:solidFill>
                 <a:latin typeface="Arial"/>
               </a:rPr>
-              <a:t>   ·   10.5% downside risk</a:t>
+              <a:t>   ·   11.1% downside risk</a:t>
             </a:r>
           </a:p>
         </p:txBody>
@@ -8522,7 +8522,7 @@
         </p:nvSpPr>
         <p:spPr>
           <a:xfrm>
-            <a:off x="6671629" y="4525670"/>
+            <a:off x="6671629" y="4369612"/>
             <a:ext cx="2494545" cy="292608"/>
           </a:xfrm>
           <a:prstGeom prst="rect">
@@ -8551,7 +8551,7 @@
                 </a:solidFill>
                 <a:latin typeface="Arial"/>
               </a:rPr>
-              <a:t>70% MSCI  /  30% Athanase</a:t>
+              <a:t>92% MSCI  /  8% Athanase</a:t>
             </a:r>
           </a:p>
         </p:txBody>
@@ -8564,8 +8564,8 @@
         </p:nvSpPr>
         <p:spPr>
           <a:xfrm>
-            <a:off x="6510690" y="5081625"/>
-            <a:ext cx="2816422" cy="780288"/>
+            <a:off x="6510690" y="4896307"/>
+            <a:ext cx="2816422" cy="292608"/>
           </a:xfrm>
           <a:prstGeom prst="rect">
             <a:avLst/>
@@ -8574,92 +8574,6 @@
         </p:spPr>
         <p:txBody>
           <a:bodyPr wrap="square" anchor="t" lIns="0" rIns="0" tIns="0" bIns="0">
-            <a:spAutoFit/>
-          </a:bodyPr>
-          <a:lstStyle/>
-          <a:p>
-            <a:pPr algn="l">
-              <a:lnSpc>
-                <a:spcPct val="120000"/>
-              </a:lnSpc>
-              <a:spcAft>
-                <a:spcPts val="0"/>
-              </a:spcAft>
-            </a:pPr>
-            <a:r>
-              <a:rPr sz="960" b="1" i="0">
-                <a:solidFill>
-                  <a:srgbClr val="152130"/>
-                </a:solidFill>
-                <a:latin typeface="Arial"/>
-              </a:rPr>
-              <a:t>+3.4 pts of return while downside risk FALLS by 1.0 pts.</a:t>
-            </a:r>
-          </a:p>
-        </p:txBody>
-      </p:sp>
-      <p:sp>
-        <p:nvSpPr>
-          <p:cNvPr id="18" name="Rectangle 17"/>
-          <p:cNvSpPr/>
-          <p:nvPr/>
-        </p:nvSpPr>
-        <p:spPr>
-          <a:xfrm>
-            <a:off x="438922" y="6456883"/>
-            <a:ext cx="8873559" cy="448665"/>
-          </a:xfrm>
-          <a:prstGeom prst="rect">
-            <a:avLst/>
-          </a:prstGeom>
-          <a:solidFill>
-            <a:srgbClr val="152130"/>
-          </a:solidFill>
-          <a:ln>
-            <a:noFill/>
-          </a:ln>
-          <a:effectLst/>
-        </p:spPr>
-        <p:style>
-          <a:lnRef idx="1">
-            <a:schemeClr val="accent1"/>
-          </a:lnRef>
-          <a:fillRef idx="3">
-            <a:schemeClr val="accent1"/>
-          </a:fillRef>
-          <a:effectRef idx="2">
-            <a:schemeClr val="accent1"/>
-          </a:effectRef>
-          <a:fontRef idx="minor">
-            <a:schemeClr val="lt1"/>
-          </a:fontRef>
-        </p:style>
-        <p:txBody>
-          <a:bodyPr rtlCol="0" anchor="ctr"/>
-          <a:lstStyle/>
-          <a:p>
-            <a:pPr algn="ctr"/>
-          </a:p>
-        </p:txBody>
-      </p:sp>
-      <p:sp>
-        <p:nvSpPr>
-          <p:cNvPr id="19" name="TextBox 18"/>
-          <p:cNvSpPr txBox="1"/>
-          <p:nvPr/>
-        </p:nvSpPr>
-        <p:spPr>
-          <a:xfrm>
-            <a:off x="570599" y="6456883"/>
-            <a:ext cx="8632151" cy="448665"/>
-          </a:xfrm>
-          <a:prstGeom prst="rect">
-            <a:avLst/>
-          </a:prstGeom>
-          <a:noFill/>
-        </p:spPr>
-        <p:txBody>
-          <a:bodyPr wrap="square" anchor="ctr" lIns="0" rIns="0" tIns="0" bIns="0">
             <a:spAutoFit/>
           </a:bodyPr>
           <a:lstStyle/>
@@ -8673,14 +8587,100 @@
               </a:spcAft>
             </a:pPr>
             <a:r>
-              <a:rPr sz="960" b="0" i="1">
-                <a:solidFill>
-                  <a:srgbClr val="FFFFFF"/>
+              <a:rPr sz="840" b="1" i="0">
+                <a:solidFill>
+                  <a:srgbClr val="314359"/>
                 </a:solidFill>
                 <a:latin typeface="Arial"/>
               </a:rPr>
-              <a:t>The blend is not a trade-off — a 30% sleeve raises return AND lowers downside risk versus holding global equities alone.</a:t>
-            </a:r>
+              <a:t>HOW TO READ IT</a:t>
+            </a:r>
+          </a:p>
+        </p:txBody>
+      </p:sp>
+      <p:sp>
+        <p:nvSpPr>
+          <p:cNvPr id="18" name="TextBox 17"/>
+          <p:cNvSpPr txBox="1"/>
+          <p:nvPr/>
+        </p:nvSpPr>
+        <p:spPr>
+          <a:xfrm>
+            <a:off x="6510690" y="5169408"/>
+            <a:ext cx="2816422" cy="1853184"/>
+          </a:xfrm>
+          <a:prstGeom prst="rect">
+            <a:avLst/>
+          </a:prstGeom>
+          <a:noFill/>
+        </p:spPr>
+        <p:txBody>
+          <a:bodyPr wrap="square" anchor="t" lIns="0" rIns="0" tIns="0" bIns="0">
+            <a:spAutoFit/>
+          </a:bodyPr>
+          <a:lstStyle/>
+          <a:p>
+            <a:pPr algn="l">
+              <a:lnSpc>
+                <a:spcPct val="116000"/>
+              </a:lnSpc>
+              <a:spcAft>
+                <a:spcPts val="0"/>
+              </a:spcAft>
+            </a:pPr>
+            <a:r>
+              <a:rPr sz="840" b="0" i="0">
+                <a:solidFill>
+                  <a:srgbClr val="0E1620"/>
+                </a:solidFill>
+                <a:latin typeface="Arial"/>
+              </a:rPr>
+              <a:t>Every blend on the curve beats holding equities alone, and the benefit keeps building until past half the portfolio (downside risk bottoms near 60%). That is a directional case to size up — within prudent limits — not a target: a 59% position would breach concentration, liquidity and the 3–8% sizing discipline. Even an 8% sleeve already moves the portfolio the right way.</a:t>
+            </a:r>
+          </a:p>
+        </p:txBody>
+      </p:sp>
+      <p:sp>
+        <p:nvSpPr>
+          <p:cNvPr id="19" name="Rectangle 18"/>
+          <p:cNvSpPr/>
+          <p:nvPr/>
+        </p:nvSpPr>
+        <p:spPr>
+          <a:xfrm>
+            <a:off x="438922" y="6456883"/>
+            <a:ext cx="8873559" cy="448665"/>
+          </a:xfrm>
+          <a:prstGeom prst="rect">
+            <a:avLst/>
+          </a:prstGeom>
+          <a:solidFill>
+            <a:srgbClr val="152130"/>
+          </a:solidFill>
+          <a:ln>
+            <a:noFill/>
+          </a:ln>
+          <a:effectLst/>
+        </p:spPr>
+        <p:style>
+          <a:lnRef idx="1">
+            <a:schemeClr val="accent1"/>
+          </a:lnRef>
+          <a:fillRef idx="3">
+            <a:schemeClr val="accent1"/>
+          </a:fillRef>
+          <a:effectRef idx="2">
+            <a:schemeClr val="accent1"/>
+          </a:effectRef>
+          <a:fontRef idx="minor">
+            <a:schemeClr val="lt1"/>
+          </a:fontRef>
+        </p:style>
+        <p:txBody>
+          <a:bodyPr rtlCol="0" anchor="ctr"/>
+          <a:lstStyle/>
+          <a:p>
+            <a:pPr algn="ctr"/>
           </a:p>
         </p:txBody>
       </p:sp>
@@ -8692,8 +8692,8 @@
         </p:nvSpPr>
         <p:spPr>
           <a:xfrm>
-            <a:off x="438922" y="6983577"/>
-            <a:ext cx="9217382" cy="390144"/>
+            <a:off x="570599" y="6456883"/>
+            <a:ext cx="8632151" cy="448665"/>
           </a:xfrm>
           <a:prstGeom prst="rect">
             <a:avLst/>
@@ -8701,7 +8701,7 @@
           <a:noFill/>
         </p:spPr>
         <p:txBody>
-          <a:bodyPr wrap="square" anchor="t" lIns="0" rIns="0" tIns="0" bIns="0">
+          <a:bodyPr wrap="square" anchor="ctr" lIns="0" rIns="0" tIns="0" bIns="0">
             <a:spAutoFit/>
           </a:bodyPr>
           <a:lstStyle/>
@@ -8715,13 +8715,55 @@
               </a:spcAft>
             </a:pPr>
             <a:r>
-              <a:rPr sz="600" b="0" i="0">
-                <a:solidFill>
-                  <a:srgbClr val="556A83"/>
+              <a:rPr sz="960" b="0" i="1">
+                <a:solidFill>
+                  <a:srgbClr val="FFFFFF"/>
                 </a:solidFill>
                 <a:latin typeface="Arial"/>
               </a:rPr>
-              <a:t>Source: monthly net returns, 235 months (2006–2025), monthly rebalanced blends. Downside volatility = annualised deviation of negative months (MAR 0). Illustrative; past performance is not indicative of future results.</a:t>
+              <a:t>The blend is not a trade-off — every allocation improves the portfolio, so the case is to size up within prudent 3–8% limits, not to chase the mathematical optimum.</a:t>
+            </a:r>
+          </a:p>
+        </p:txBody>
+      </p:sp>
+      <p:sp>
+        <p:nvSpPr>
+          <p:cNvPr id="21" name="TextBox 20"/>
+          <p:cNvSpPr txBox="1"/>
+          <p:nvPr/>
+        </p:nvSpPr>
+        <p:spPr>
+          <a:xfrm>
+            <a:off x="438922" y="6983577"/>
+            <a:ext cx="9217382" cy="390144"/>
+          </a:xfrm>
+          <a:prstGeom prst="rect">
+            <a:avLst/>
+          </a:prstGeom>
+          <a:noFill/>
+        </p:spPr>
+        <p:txBody>
+          <a:bodyPr wrap="square" anchor="t" lIns="0" rIns="0" tIns="0" bIns="0">
+            <a:spAutoFit/>
+          </a:bodyPr>
+          <a:lstStyle/>
+          <a:p>
+            <a:pPr algn="l">
+              <a:lnSpc>
+                <a:spcPct val="110000"/>
+              </a:lnSpc>
+              <a:spcAft>
+                <a:spcPts val="0"/>
+              </a:spcAft>
+            </a:pPr>
+            <a:r>
+              <a:rPr sz="600" b="0" i="0">
+                <a:solidFill>
+                  <a:srgbClr val="556A83"/>
+                </a:solidFill>
+                <a:latin typeface="Arial"/>
+              </a:rPr>
+              <a:t>Source: monthly net returns, 235 months (2006–2025), monthly rebalanced blends. Downside volatility = annualised deviation of negative months (MAR 0). The minimum-risk point is in-sample and shown for shape, not as advice. Illustrative; past performance is not indicative of future results.</a:t>
             </a:r>
           </a:p>
         </p:txBody>

</xml_diff>